<commit_message>
Geometry fit on registered-overlap ratios: monotonic tilt shift, offset sign corrected; tilt angle quoted as upper bound; talk and Results draft updated
</commit_message>
<xml_diff>
--- a/presentation/dual_detector_talk.pptx
+++ b/presentation/dual_detector_talk.pptx
@@ -891,7 +891,7 @@
           </a:p>
           <a:p>
             <a:r>
-              <a:t>Table 1 in one look. Two messages: the channels are far from interchangeable (6x at calcium), and tilting produces a highly significant, sign-changing pattern. The four lead lines are the internal control - same pixels, same composition, only energy differs.</a:t>
+              <a:t>Table 1 in one look. Two messages: the channels are far from interchangeable (6x at calcium), and tilting produces a highly significant, monotonically decaying energy pattern. Mention the crop test: restricting to the registered overlap removed a field-of-view artifact - that is why these are the trustworthy numbers. The four lead lines are the internal control - same pixels, same composition, only energy differs.</a:t>
             </a:r>
           </a:p>
         </p:txBody>
@@ -1116,7 +1116,7 @@
           </a:p>
           <a:p>
             <a:r>
-              <a:t>The mounting angle was never recorded - and it turns out we never needed it. The tilt compresses the image vertically, and the scan step sizes cancel in the scale ratio, so the angle falls out of registration: 7.7 degrees. The precision floor itself is a result: it is the positioning drift between two nominally identical sessions.</a:t>
+              <a:t>The mounting angle was never recorded - and it turns out we never needed it. The tilt compresses the image vertically, and the scan step sizes cancel in the scale ratio, so the angle falls out of registration: about 8 degrees. Be upfront: a control pair with no tilt returns five degrees, so we quote it as an upper bound until the instrument builder confirms. The precision floor itself is a result: it is the positioning drift between two nominally identical sessions.</a:t>
             </a:r>
           </a:p>
         </p:txBody>
@@ -4463,7 +4463,7 @@
                 </a:solidFill>
                 <a:latin typeface="Calibri"/>
               </a:rPr>
-              <a:t>Per-element efficiency ratios with uncertainties, spanning 6.0 to 0.65</a:t>
+              <a:t>Per-element efficiency ratios with uncertainties, spanning 5.8 to 0.63</a:t>
             </a:r>
           </a:p>
           <a:p>
@@ -4488,7 +4488,7 @@
                 </a:solidFill>
                 <a:latin typeface="Calibri"/>
               </a:rPr>
-              <a:t>Detector vs geometry cleanly separated; effective take-off response 0.5°/° of tilt; matrix scale Ec = 3.75 keV</a:t>
+              <a:t>Detector vs geometry cleanly separated; effective take-off response 0.5°/° of tilt; matrix scale Ec ≈ 3.6 keV</a:t>
             </a:r>
           </a:p>
           <a:p>
@@ -4513,7 +4513,7 @@
                 </a:solidFill>
                 <a:latin typeface="Calibri"/>
               </a:rPr>
-              <a:t>The data self-report their geometry: tilt 7.7°, session drift 0.43 %</a:t>
+              <a:t>The data self-report their geometry: tilt ≲ 8°, session drift 0.43 %</a:t>
             </a:r>
           </a:p>
           <a:p>
@@ -4822,7 +4822,7 @@
         <p:spPr>
           <a:xfrm>
             <a:off x="502920" y="1554480"/>
-            <a:ext cx="4527161" cy="4206240"/>
+            <a:ext cx="4530516" cy="4206240"/>
           </a:xfrm>
           <a:prstGeom prst="rect">
             <a:avLst/>
@@ -5453,7 +5453,7 @@
                           </a:solidFill>
                           <a:latin typeface="Calibri"/>
                         </a:rPr>
-                        <a:t>6.03</a:t>
+                        <a:t>5.78</a:t>
                       </a:r>
                     </a:p>
                   </a:txBody>
@@ -5471,7 +5471,7 @@
                           </a:solidFill>
                           <a:latin typeface="Calibri"/>
                         </a:rPr>
-                        <a:t>+4.9 %</a:t>
+                        <a:t>+9.5 %</a:t>
                       </a:r>
                     </a:p>
                   </a:txBody>
@@ -5489,7 +5489,7 @@
                           </a:solidFill>
                           <a:latin typeface="Calibri"/>
                         </a:rPr>
-                        <a:t>13σ</a:t>
+                        <a:t>24σ</a:t>
                       </a:r>
                     </a:p>
                   </a:txBody>
@@ -5545,7 +5545,7 @@
                           </a:solidFill>
                           <a:latin typeface="Calibri"/>
                         </a:rPr>
-                        <a:t>2.54</a:t>
+                        <a:t>2.42</a:t>
                       </a:r>
                     </a:p>
                   </a:txBody>
@@ -5563,7 +5563,7 @@
                           </a:solidFill>
                           <a:latin typeface="Calibri"/>
                         </a:rPr>
-                        <a:t>+2.9 %</a:t>
+                        <a:t>+7.9 %</a:t>
                       </a:r>
                     </a:p>
                   </a:txBody>
@@ -5581,7 +5581,7 @@
                           </a:solidFill>
                           <a:latin typeface="Calibri"/>
                         </a:rPr>
-                        <a:t>5.6σ</a:t>
+                        <a:t>13.5σ</a:t>
                       </a:r>
                     </a:p>
                   </a:txBody>
@@ -5637,7 +5637,7 @@
                           </a:solidFill>
                           <a:latin typeface="Calibri"/>
                         </a:rPr>
-                        <a:t>1.24</a:t>
+                        <a:t>1.21</a:t>
                       </a:r>
                     </a:p>
                   </a:txBody>
@@ -5649,13 +5649,13 @@
                     <a:lstStyle/>
                     <a:p>
                       <a:r>
-                        <a:rPr sz="1400">
+                        <a:rPr sz="1400" b="1">
                           <a:solidFill>
-                            <a:srgbClr val="262626"/>
+                            <a:srgbClr val="D95F02"/>
                           </a:solidFill>
                           <a:latin typeface="Calibri"/>
                         </a:rPr>
-                        <a:t>+0.9 %</a:t>
+                        <a:t>+3.5 %</a:t>
                       </a:r>
                     </a:p>
                   </a:txBody>
@@ -5667,13 +5667,13 @@
                     <a:lstStyle/>
                     <a:p>
                       <a:r>
-                        <a:rPr sz="1400">
+                        <a:rPr sz="1400" b="1">
                           <a:solidFill>
-                            <a:srgbClr val="262626"/>
+                            <a:srgbClr val="D95F02"/>
                           </a:solidFill>
                           <a:latin typeface="Calibri"/>
                         </a:rPr>
-                        <a:t>2.4σ</a:t>
+                        <a:t>9.2σ</a:t>
                       </a:r>
                     </a:p>
                   </a:txBody>
@@ -5729,7 +5729,7 @@
                           </a:solidFill>
                           <a:latin typeface="Calibri"/>
                         </a:rPr>
-                        <a:t>1.08</a:t>
+                        <a:t>1.01</a:t>
                       </a:r>
                     </a:p>
                   </a:txBody>
@@ -5741,13 +5741,13 @@
                     <a:lstStyle/>
                     <a:p>
                       <a:r>
-                        <a:rPr sz="1400" b="1">
+                        <a:rPr sz="1400">
                           <a:solidFill>
-                            <a:srgbClr val="D95F02"/>
+                            <a:srgbClr val="262626"/>
                           </a:solidFill>
                           <a:latin typeface="Calibri"/>
                         </a:rPr>
-                        <a:t>−3.7 %</a:t>
+                        <a:t>+2.5 %</a:t>
                       </a:r>
                     </a:p>
                   </a:txBody>
@@ -5759,13 +5759,13 @@
                     <a:lstStyle/>
                     <a:p>
                       <a:r>
-                        <a:rPr sz="1400" b="1">
+                        <a:rPr sz="1400">
                           <a:solidFill>
-                            <a:srgbClr val="D95F02"/>
+                            <a:srgbClr val="262626"/>
                           </a:solidFill>
                           <a:latin typeface="Calibri"/>
                         </a:rPr>
-                        <a:t>8σ</a:t>
+                        <a:t>4.6σ</a:t>
                       </a:r>
                     </a:p>
                   </a:txBody>
@@ -5821,7 +5821,7 @@
                           </a:solidFill>
                           <a:latin typeface="Calibri"/>
                         </a:rPr>
-                        <a:t>0.860</a:t>
+                        <a:t>0.828</a:t>
                       </a:r>
                     </a:p>
                   </a:txBody>
@@ -5833,13 +5833,13 @@
                     <a:lstStyle/>
                     <a:p>
                       <a:r>
-                        <a:rPr sz="1400">
+                        <a:rPr sz="1400" b="1">
                           <a:solidFill>
-                            <a:srgbClr val="262626"/>
+                            <a:srgbClr val="D95F02"/>
                           </a:solidFill>
                           <a:latin typeface="Calibri"/>
                         </a:rPr>
-                        <a:t>+0.3 %</a:t>
+                        <a:t>+4.1 %</a:t>
                       </a:r>
                     </a:p>
                   </a:txBody>
@@ -5851,13 +5851,13 @@
                     <a:lstStyle/>
                     <a:p>
                       <a:r>
-                        <a:rPr sz="1400">
+                        <a:rPr sz="1400" b="1">
                           <a:solidFill>
-                            <a:srgbClr val="262626"/>
+                            <a:srgbClr val="D95F02"/>
                           </a:solidFill>
                           <a:latin typeface="Calibri"/>
                         </a:rPr>
-                        <a:t>0.4σ</a:t>
+                        <a:t>5.6σ</a:t>
                       </a:r>
                     </a:p>
                   </a:txBody>
@@ -5913,7 +5913,7 @@
                           </a:solidFill>
                           <a:latin typeface="Calibri"/>
                         </a:rPr>
-                        <a:t>0.800</a:t>
+                        <a:t>0.765</a:t>
                       </a:r>
                     </a:p>
                   </a:txBody>
@@ -5931,7 +5931,7 @@
                           </a:solidFill>
                           <a:latin typeface="Calibri"/>
                         </a:rPr>
-                        <a:t>−2.3 %</a:t>
+                        <a:t>+2.2 %</a:t>
                       </a:r>
                     </a:p>
                   </a:txBody>
@@ -5949,7 +5949,7 @@
                           </a:solidFill>
                           <a:latin typeface="Calibri"/>
                         </a:rPr>
-                        <a:t>13.5σ</a:t>
+                        <a:t>11.5σ</a:t>
                       </a:r>
                     </a:p>
                   </a:txBody>
@@ -6005,7 +6005,7 @@
                           </a:solidFill>
                           <a:latin typeface="Calibri"/>
                         </a:rPr>
-                        <a:t>0.727</a:t>
+                        <a:t>0.699</a:t>
                       </a:r>
                     </a:p>
                   </a:txBody>
@@ -6023,7 +6023,7 @@
                           </a:solidFill>
                           <a:latin typeface="Calibri"/>
                         </a:rPr>
-                        <a:t>−2.2 %</a:t>
+                        <a:t>+1.8 %</a:t>
                       </a:r>
                     </a:p>
                   </a:txBody>
@@ -6041,7 +6041,7 @@
                           </a:solidFill>
                           <a:latin typeface="Calibri"/>
                         </a:rPr>
-                        <a:t>14σ</a:t>
+                        <a:t>10.3σ</a:t>
                       </a:r>
                     </a:p>
                   </a:txBody>
@@ -6097,7 +6097,7 @@
                           </a:solidFill>
                           <a:latin typeface="Calibri"/>
                         </a:rPr>
-                        <a:t>0.650</a:t>
+                        <a:t>0.630</a:t>
                       </a:r>
                     </a:p>
                   </a:txBody>
@@ -6109,13 +6109,13 @@
                     <a:lstStyle/>
                     <a:p>
                       <a:r>
-                        <a:rPr sz="1400" b="1">
+                        <a:rPr sz="1400">
                           <a:solidFill>
-                            <a:srgbClr val="D95F02"/>
+                            <a:srgbClr val="262626"/>
                           </a:solidFill>
                           <a:latin typeface="Calibri"/>
                         </a:rPr>
-                        <a:t>−2.5 %</a:t>
+                        <a:t>+0.6 %</a:t>
                       </a:r>
                     </a:p>
                   </a:txBody>
@@ -6127,13 +6127,13 @@
                     <a:lstStyle/>
                     <a:p>
                       <a:r>
-                        <a:rPr sz="1400" b="1">
+                        <a:rPr sz="1400">
                           <a:solidFill>
-                            <a:srgbClr val="D95F02"/>
+                            <a:srgbClr val="262626"/>
                           </a:solidFill>
                           <a:latin typeface="Calibri"/>
                         </a:rPr>
-                        <a:t>8.5σ</a:t>
+                        <a:t>1.8σ</a:t>
                       </a:r>
                     </a:p>
                   </a:txBody>
@@ -6187,7 +6187,7 @@
                 </a:solidFill>
                 <a:latin typeface="Calibri"/>
               </a:rPr>
-              <a:t>Same pixels, same painting: the frontal ratio runs from 6.0 down to 0.65 across energy</a:t>
+              <a:t>Same pixels, same painting: the frontal ratio runs from 5.8 down to 0.63 across energy</a:t>
             </a:r>
           </a:p>
           <a:p>
@@ -6212,7 +6212,7 @@
                 </a:solidFill>
                 <a:latin typeface="Calibri"/>
               </a:rPr>
-              <a:t>Frontal repeatability ≤ 1.4 % - the tilt moves the ratio 3-14σ above it</a:t>
+              <a:t>Frontal repeatability ≤ 1.4 % - the tilt moves the ratio up to 24σ above it</a:t>
             </a:r>
           </a:p>
           <a:p>
@@ -6237,7 +6237,7 @@
                 </a:solidFill>
                 <a:latin typeface="Calibri"/>
               </a:rPr>
-              <a:t>The shift changes sign with energy - geometry, not drift</a:t>
+              <a:t>The shift decays monotonically with energy, +9.5 % → +0.6 % - geometry, not drift</a:t>
             </a:r>
           </a:p>
           <a:p>
@@ -6262,7 +6262,32 @@
                 </a:solidFill>
                 <a:latin typeface="Calibri"/>
               </a:rPr>
-              <a:t>Four Pb lines share pixels and composition: a pure energy dependence, immune to the field-of-view objection</a:t>
+              <a:t>Ratios from the registered overlap region only: a crop test showed full-frame ratios mix in a field-of-view artifact</a:t>
+            </a:r>
+          </a:p>
+          <a:p>
+            <a:pPr>
+              <a:spcAft>
+                <a:spcPts val="1200"/>
+              </a:spcAft>
+            </a:pPr>
+            <a:r>
+              <a:rPr sz="1700" b="0" i="0">
+                <a:solidFill>
+                  <a:srgbClr val="595959"/>
+                </a:solidFill>
+                <a:latin typeface="Calibri"/>
+              </a:rPr>
+              <a:t>•  </a:t>
+            </a:r>
+            <a:r>
+              <a:rPr sz="1700" b="0" i="0">
+                <a:solidFill>
+                  <a:srgbClr val="262626"/>
+                </a:solidFill>
+                <a:latin typeface="Calibri"/>
+              </a:rPr>
+              <a:t>Four Pb lines share pixels and composition: a pure energy dependence</a:t>
             </a:r>
           </a:p>
         </p:txBody>
@@ -6642,7 +6667,7 @@
                 </a:solidFill>
                 <a:latin typeface="Calibri"/>
               </a:rPr>
-              <a:t>Tilt shift of R: positive below 6 keV, zero crossing near 6.5 keV, negative plateau above</a:t>
+              <a:t>Tilt shift of R: monotonic positive decay, +9.5 % at 3.7 keV → +0.6 % at 14.8 keV</a:t>
             </a:r>
           </a:p>
           <a:p>
@@ -6692,7 +6717,7 @@
                 </a:solidFill>
                 <a:latin typeface="Calibri"/>
               </a:rPr>
-              <a:t>Lever arm s = 0.48 ± 0.07 ⇒ take-off shift 3.7° ± 0.6° at this tilt</a:t>
+              <a:t>Lever arm s = 0.53 ± 0.10 ⇒ take-off shift 4.1° ± 0.8° at this tilt</a:t>
             </a:r>
           </a:p>
           <a:p>
@@ -6717,7 +6742,7 @@
                 </a:solidFill>
                 <a:latin typeface="Calibri"/>
               </a:rPr>
-              <a:t>Gaussian-process check (no physics inside): same shape, model within 0.9σ</a:t>
+              <a:t>Gaussian-process check (no physics inside): same shape, model within 1.1σ</a:t>
             </a:r>
           </a:p>
           <a:p>
@@ -6921,7 +6946,7 @@
                 </a:solidFill>
                 <a:latin typeface="Calibri"/>
               </a:rPr>
-              <a:t>θ = 7.7° ± 1.0° (elements) ± 1.8° (floor)</a:t>
+              <a:t>θ = 7.7° ± 1.0° ± 1.8° - an upper bound (θ ≲ 8°)</a:t>
             </a:r>
           </a:p>
           <a:p>
@@ -6946,7 +6971,7 @@
                 </a:solidFill>
                 <a:latin typeface="Calibri"/>
               </a:rPr>
-              <a:t>Five elements agree; the three-scan consistency triangle closes</a:t>
+              <a:t>A no-tilt control pair returns “5.3°”: foreshortening at this angle sits near the resolution floor</a:t>
             </a:r>
           </a:p>
           <a:p>

</xml_diff>

<commit_message>
Talk updated with delivered results: fusion benchmark on slide 9, learned-fusion headline in conclusions, absorber 973 um aligned with the overlap fit
</commit_message>
<xml_diff>
--- a/presentation/dual_detector_talk.pptx
+++ b/presentation/dual_detector_talk.pptx
@@ -591,7 +591,7 @@
           </a:p>
           <a:p>
             <a:r>
-              <a:t>One sentence to leave with: the signal everyone throws away is enough to characterize the instrument - including the angle nobody wrote down. Thank you; happy to take questions.</a:t>
+              <a:t>One sentence to leave with: the signal everyone throws away is enough to characterize the instrument - including the angle nobody wrote down - and, once characterized, the two channels fuse into a better measurement than their sum. Thank you; happy to take questions.</a:t>
             </a:r>
           </a:p>
         </p:txBody>
@@ -1191,7 +1191,7 @@
           </a:p>
           <a:p>
             <a:r>
-              <a:t>What this is for, in practice. Each item reuses the numbers from the previous slides: the ratios weight the fusion, the tilt response prices a mounting error, the per-pixel ratios map the canvas relief. These are being finalized for the paper.</a:t>
+              <a:t>Everything here reuses the earlier numbers. The flat-field is reproducible and is literally the scatter-artifact geometry - one acquisition story. The weighting null is itself a finding: the channels are Poisson-limited, no scalar reweighting can win. The learned fusion goes beyond scalars: two detectors are two noise realizations of the same spectrum - Noise2Noise, no clean targets - and it gains 17.7 percent on pixels it never trained on. We quote it only where the absolute level is preserved; Ca and Ti stay on the sum. If asked: validation MSE does not rank these models like map SNR does - MSE rewards shrinking to the mean; hence the contrast guard.</a:t>
             </a:r>
           </a:p>
         </p:txBody>
@@ -4333,7 +4333,7 @@
                 </a:solidFill>
                 <a:latin typeface="Calibri"/>
               </a:rPr>
-              <a:t>Heidelberg, 2026</a:t>
+              <a:t>EuCAIFCon 2026 - Heidelberg</a:t>
             </a:r>
           </a:p>
         </p:txBody>
@@ -4463,7 +4463,7 @@
                 </a:solidFill>
                 <a:latin typeface="Calibri"/>
               </a:rPr>
-              <a:t>Per-element efficiency ratios with uncertainties, spanning 5.8 to 0.63</a:t>
+              <a:t>Per-element efficiency ratios (5.8 → 0.63); detector vs geometry separated: take-off response 0.5°/°, matrix scale Ec ≈ 3.6 keV</a:t>
             </a:r>
           </a:p>
           <a:p>
@@ -4482,13 +4482,13 @@
               <a:t>•  </a:t>
             </a:r>
             <a:r>
-              <a:rPr sz="1700" b="0" i="0">
+              <a:rPr sz="1700" b="1" i="0">
                 <a:solidFill>
                   <a:srgbClr val="262626"/>
                 </a:solidFill>
                 <a:latin typeface="Calibri"/>
               </a:rPr>
-              <a:t>Detector vs geometry cleanly separated; effective take-off response 0.5°/° of tilt; matrix scale Ec ≈ 3.6 keV</a:t>
+              <a:t>Self-supervised fusion of the two channels: +17.7 % SNR over summing on held-out pixels</a:t>
             </a:r>
           </a:p>
           <a:p>
@@ -4513,7 +4513,7 @@
                 </a:solidFill>
                 <a:latin typeface="Calibri"/>
               </a:rPr>
-              <a:t>The data self-report their geometry: tilt ≲ 8°, session drift 0.43 %</a:t>
+              <a:t>The data self-report their geometry: tilt ≲ 8°, session drift 0.43 %, flat-field = the artifact geometry</a:t>
             </a:r>
           </a:p>
           <a:p>
@@ -6467,7 +6467,7 @@
                 </a:solidFill>
                 <a:latin typeface="Calibri"/>
               </a:rPr>
-              <a:t>Fitted absorber: 974 ± 1 µm Be-equivalent</a:t>
+              <a:t>Fitted absorber: 973 ± 2 µm Be-equivalent</a:t>
             </a:r>
             <a:r>
               <a:rPr sz="1700" b="0" i="0">
@@ -7080,7 +7080,7 @@
                 </a:solidFill>
                 <a:latin typeface="Calibri"/>
               </a:rPr>
-              <a:t>ongoing - full results in the paper</a:t>
+              <a:t>fusion benchmark: cross-scan SNR on held-out pixels</a:t>
             </a:r>
           </a:p>
         </p:txBody>
@@ -7093,8 +7093,8 @@
         </p:nvSpPr>
         <p:spPr>
           <a:xfrm>
-            <a:off x="822960" y="1645920"/>
-            <a:ext cx="10545775" cy="4206240"/>
+            <a:off x="640080" y="1325880"/>
+            <a:ext cx="10911535" cy="1920240"/>
           </a:xfrm>
           <a:prstGeom prst="rect">
             <a:avLst/>
@@ -7109,7 +7109,7 @@
           <a:p>
             <a:pPr>
               <a:spcAft>
-                <a:spcPts val="1600"/>
+                <a:spcPts val="800"/>
               </a:spcAft>
             </a:pPr>
             <a:r>
@@ -7122,28 +7122,28 @@
               <a:t>•  </a:t>
             </a:r>
             <a:r>
-              <a:rPr sz="1800" b="1" i="0">
+              <a:rPr sz="1500" b="1" i="0">
                 <a:solidFill>
                   <a:srgbClr val="262626"/>
                 </a:solidFill>
                 <a:latin typeface="Calibri"/>
               </a:rPr>
-              <a:t>Geometric non-uniformity map</a:t>
-            </a:r>
-            <a:r>
-              <a:rPr sz="1800" b="0" i="0">
+              <a:t>Flat-field map</a:t>
+            </a:r>
+            <a:r>
+              <a:rPr sz="1500" b="0" i="0">
                 <a:solidFill>
                   <a:srgbClr val="262626"/>
                 </a:solidFill>
                 <a:latin typeface="Calibri"/>
               </a:rPr>
-              <a:t> from registered log-ratio maps - the “flat-field” of the abstract</a:t>
+              <a:t>: RMS ≈ 9 %, reproduced across scans (r = 0.70) - and it is the scatter-artifact geometry (r = 0.86)</a:t>
             </a:r>
           </a:p>
           <a:p>
             <a:pPr>
               <a:spcAft>
-                <a:spcPts val="1600"/>
+                <a:spcPts val="800"/>
               </a:spcAft>
             </a:pPr>
             <a:r>
@@ -7156,28 +7156,28 @@
               <a:t>•  </a:t>
             </a:r>
             <a:r>
-              <a:rPr sz="1800" b="1" i="0">
+              <a:rPr sz="1500" b="1" i="0">
                 <a:solidFill>
                   <a:srgbClr val="262626"/>
                 </a:solidFill>
                 <a:latin typeface="Calibri"/>
               </a:rPr>
-              <a:t>Detector fusion</a:t>
-            </a:r>
-            <a:r>
-              <a:rPr sz="1800" b="0" i="0">
+              <a:t>Mounting-error price list</a:t>
+            </a:r>
+            <a:r>
+              <a:rPr sz="1500" b="0" i="0">
                 <a:solidFill>
                   <a:srgbClr val="262626"/>
                 </a:solidFill>
                 <a:latin typeface="Calibri"/>
               </a:rPr>
-              <a:t> weighted by the measured efficiency ratios - and a learned, self-supervised variant (two detectors = two independent noise realizations)</a:t>
+              <a:t>: 0.50 %/° (Ca), 0.45 %/° (Ti), ≤ 0.13 %/° (Pb) - lower bounds</a:t>
             </a:r>
           </a:p>
           <a:p>
             <a:pPr>
               <a:spcAft>
-                <a:spcPts val="1600"/>
+                <a:spcPts val="800"/>
               </a:spcAft>
             </a:pPr>
             <a:r>
@@ -7190,60 +7190,68 @@
               <a:t>•  </a:t>
             </a:r>
             <a:r>
-              <a:rPr sz="1800" b="1" i="0">
+              <a:rPr sz="1500" b="1" i="0">
                 <a:solidFill>
                   <a:srgbClr val="262626"/>
                 </a:solidFill>
                 <a:latin typeface="Calibri"/>
               </a:rPr>
-              <a:t>Mounting-error estimate</a:t>
-            </a:r>
-            <a:r>
-              <a:rPr sz="1800" b="0" i="0">
+              <a:t>Fusion</a:t>
+            </a:r>
+            <a:r>
+              <a:rPr sz="1500" b="0" i="0">
                 <a:solidFill>
                   <a:srgbClr val="262626"/>
                 </a:solidFill>
                 <a:latin typeface="Calibri"/>
               </a:rPr>
-              <a:t> per element, in %/degree, from the measured tilt response</a:t>
-            </a:r>
-          </a:p>
-          <a:p>
-            <a:pPr>
-              <a:spcAft>
-                <a:spcPts val="1600"/>
-              </a:spcAft>
-            </a:pPr>
-            <a:r>
-              <a:rPr sz="1700" b="0" i="0">
-                <a:solidFill>
-                  <a:srgbClr val="595959"/>
-                </a:solidFill>
-                <a:latin typeface="Calibri"/>
-              </a:rPr>
-              <a:t>•  </a:t>
-            </a:r>
-            <a:r>
-              <a:rPr sz="1800" b="1" i="0">
+              <a:t>: inverse-variance +0.9 % - the null is a finding (Poisson-limited channels); </a:t>
+            </a:r>
+            <a:r>
+              <a:rPr sz="1500" b="1" i="0">
+                <a:solidFill>
+                  <a:srgbClr val="D95F02"/>
+                </a:solidFill>
+                <a:latin typeface="Calibri"/>
+              </a:rPr>
+              <a:t>learned N2N +17.7 % mean SNR</a:t>
+            </a:r>
+            <a:r>
+              <a:rPr sz="1500" b="0" i="0">
                 <a:solidFill>
                   <a:srgbClr val="262626"/>
                 </a:solidFill>
                 <a:latin typeface="Calibri"/>
               </a:rPr>
-              <a:t>Canvas-topography map</a:t>
-            </a:r>
-            <a:r>
-              <a:rPr sz="1800" b="0" i="0">
-                <a:solidFill>
-                  <a:srgbClr val="262626"/>
-                </a:solidFill>
-                <a:latin typeface="Calibri"/>
-              </a:rPr>
-              <a:t> - per-pixel tilt regression from a single frontal scan</a:t>
-            </a:r>
-          </a:p>
-        </p:txBody>
-      </p:sp>
+              <a:t> (six lines from Fe up, Pb Ll +69 %; Ca/Ti kept on the sum)</a:t>
+            </a:r>
+          </a:p>
+        </p:txBody>
+      </p:sp>
+      <p:pic>
+        <p:nvPicPr>
+          <p:cNvPr id="4" name="Picture 3" descr="fusion_benchmark.png"/>
+          <p:cNvPicPr>
+            <a:picLocks noChangeAspect="1"/>
+          </p:cNvPicPr>
+          <p:nvPr/>
+        </p:nvPicPr>
+        <p:blipFill>
+          <a:blip r:embed="rId2"/>
+          <a:stretch>
+            <a:fillRect/>
+          </a:stretch>
+        </p:blipFill>
+        <p:spPr>
+          <a:xfrm>
+            <a:off x="1069848" y="3154680"/>
+            <a:ext cx="10058400" cy="3657600"/>
+          </a:xfrm>
+          <a:prstGeom prst="rect">
+            <a:avLst/>
+          </a:prstGeom>
+        </p:spPr>
+      </p:pic>
     </p:spTree>
   </p:cSld>
   <p:clrMapOvr>

</xml_diff>

<commit_message>
Closure test, per-pixel weighting null, fusion showcase, canvas topography in degrees; calibrated integral-anchored N2N (+15.2% held-out, worst bias 8%); talk: delivered results and backup slides
</commit_message>
<xml_diff>
--- a/presentation/dual_detector_talk.pptx
+++ b/presentation/dual_detector_talk.pptx
@@ -15,6 +15,8 @@
     <p:sldId id="263" r:id="rId15"/>
     <p:sldId id="264" r:id="rId16"/>
     <p:sldId id="265" r:id="rId17"/>
+    <p:sldId id="266" r:id="rId18"/>
+    <p:sldId id="267" r:id="rId19"/>
   </p:sldIdLst>
   <p:sldSz cx="12191695" cy="6858000" type="screen4x3"/>
   <p:notesSz cx="6858000" cy="9144000"/>
@@ -592,6 +594,146 @@
           <a:p>
             <a:r>
               <a:t>One sentence to leave with: the signal everyone throws away is enough to characterize the instrument - including the angle nobody wrote down - and, once characterized, the two channels fuse into a better measurement than their sum. Thank you; happy to take questions.</a:t>
+            </a:r>
+          </a:p>
+        </p:txBody>
+      </p:sp>
+      <p:sp>
+        <p:nvSpPr>
+          <p:cNvPr id="4" name="Slide Number Placeholder 3"/>
+          <p:cNvSpPr>
+            <a:spLocks noGrp="1"/>
+          </p:cNvSpPr>
+          <p:nvPr>
+            <p:ph type="sldNum" idx="5" sz="quarter"/>
+          </p:nvPr>
+        </p:nvSpPr>
+        <p:spPr/>
+      </p:sp>
+    </p:spTree>
+  </p:cSld>
+  <p:clrMapOvr>
+    <a:masterClrMapping/>
+  </p:clrMapOvr>
+</p:notes>
+</file>
+
+<file path=ppt/notesSlides/notesSlide11.xml><?xml version="1.0" encoding="utf-8"?>
+<p:notes xmlns:a="http://schemas.openxmlformats.org/drawingml/2006/main" xmlns:p="http://schemas.openxmlformats.org/presentationml/2006/main" xmlns:r="http://schemas.openxmlformats.org/officeDocument/2006/relationships">
+  <p:cSld>
+    <p:spTree>
+      <p:nvGrpSpPr>
+        <p:cNvPr id="1" name=""/>
+        <p:cNvGrpSpPr/>
+        <p:nvPr/>
+      </p:nvGrpSpPr>
+      <p:grpSpPr>
+        <a:xfrm>
+          <a:off x="0" y="0"/>
+          <a:ext cx="0" cy="0"/>
+          <a:chOff x="0" y="0"/>
+          <a:chExt cx="0" cy="0"/>
+        </a:xfrm>
+      </p:grpSpPr>
+      <p:sp>
+        <p:nvSpPr>
+          <p:cNvPr id="2" name="Slide Image Placeholder 1"/>
+          <p:cNvSpPr>
+            <a:spLocks noGrp="1"/>
+          </p:cNvSpPr>
+          <p:nvPr>
+            <p:ph type="sldImg" idx="2"/>
+          </p:nvPr>
+        </p:nvSpPr>
+        <p:spPr/>
+      </p:sp>
+      <p:sp>
+        <p:nvSpPr>
+          <p:cNvPr id="3" name="Notes Placeholder 2"/>
+          <p:cNvSpPr>
+            <a:spLocks noGrp="1"/>
+          </p:cNvSpPr>
+          <p:nvPr>
+            <p:ph type="body" idx="3" sz="quarter"/>
+          </p:nvPr>
+        </p:nvSpPr>
+        <p:spPr/>
+        <p:txBody>
+          <a:bodyPr/>
+          <a:lstStyle/>
+          <a:p>
+            <a:r>
+              <a:t>BACKUP - not part of the 8:00. If asked how the fusion gain looks in practice: same signal structure, visibly calmer noise panels; Pb Ll 5.4 to 9.1, Fe 10.6 to 13.7 on pixels the network never trained on. Contrast guard cv = 0.91-0.99: not blurring.</a:t>
+            </a:r>
+          </a:p>
+        </p:txBody>
+      </p:sp>
+      <p:sp>
+        <p:nvSpPr>
+          <p:cNvPr id="4" name="Slide Number Placeholder 3"/>
+          <p:cNvSpPr>
+            <a:spLocks noGrp="1"/>
+          </p:cNvSpPr>
+          <p:nvPr>
+            <p:ph type="sldNum" idx="5" sz="quarter"/>
+          </p:nvPr>
+        </p:nvSpPr>
+        <p:spPr/>
+      </p:sp>
+    </p:spTree>
+  </p:cSld>
+  <p:clrMapOvr>
+    <a:masterClrMapping/>
+  </p:clrMapOvr>
+</p:notes>
+</file>
+
+<file path=ppt/notesSlides/notesSlide12.xml><?xml version="1.0" encoding="utf-8"?>
+<p:notes xmlns:a="http://schemas.openxmlformats.org/drawingml/2006/main" xmlns:p="http://schemas.openxmlformats.org/presentationml/2006/main" xmlns:r="http://schemas.openxmlformats.org/officeDocument/2006/relationships">
+  <p:cSld>
+    <p:spTree>
+      <p:nvGrpSpPr>
+        <p:cNvPr id="1" name=""/>
+        <p:cNvGrpSpPr/>
+        <p:nvPr/>
+      </p:nvGrpSpPr>
+      <p:grpSpPr>
+        <a:xfrm>
+          <a:off x="0" y="0"/>
+          <a:ext cx="0" cy="0"/>
+          <a:chOff x="0" y="0"/>
+          <a:chExt cx="0" cy="0"/>
+        </a:xfrm>
+      </p:grpSpPr>
+      <p:sp>
+        <p:nvSpPr>
+          <p:cNvPr id="2" name="Slide Image Placeholder 1"/>
+          <p:cNvSpPr>
+            <a:spLocks noGrp="1"/>
+          </p:cNvSpPr>
+          <p:nvPr>
+            <p:ph type="sldImg" idx="2"/>
+          </p:nvPr>
+        </p:nvSpPr>
+        <p:spPr/>
+      </p:sp>
+      <p:sp>
+        <p:nvSpPr>
+          <p:cNvPr id="3" name="Notes Placeholder 2"/>
+          <p:cNvSpPr>
+            <a:spLocks noGrp="1"/>
+          </p:cNvSpPr>
+          <p:nvPr>
+            <p:ph type="body" idx="3" sz="quarter"/>
+          </p:nvPr>
+        </p:nvSpPr>
+        <p:spPr/>
+        <p:txBody>
+          <a:bodyPr/>
+          <a:lstStyle/>
+          <a:p>
+            <a:r>
+              <a:t>BACKUP - not part of the 8:00. Use if the abstract-vs-talk difference on viewing angles comes up: the abstract promised per-detector angles; with one tilt only the response is identifiable, and the per-detector values need the nominal head geometry from the instrument builder.</a:t>
             </a:r>
           </a:p>
         </p:txBody>
@@ -4550,6 +4692,283 @@
                 <a:latin typeface="Calibri"/>
               </a:rPr>
               <a:t>Data and code: github.com/JankoVukobratovic/VincaInternship</a:t>
+            </a:r>
+          </a:p>
+        </p:txBody>
+      </p:sp>
+    </p:spTree>
+  </p:cSld>
+  <p:clrMapOvr>
+    <a:masterClrMapping/>
+  </p:clrMapOvr>
+</p:sld>
+</file>
+
+<file path=ppt/slides/slide11.xml><?xml version="1.0" encoding="utf-8"?>
+<p:sld xmlns:a="http://schemas.openxmlformats.org/drawingml/2006/main" xmlns:p="http://schemas.openxmlformats.org/presentationml/2006/main" xmlns:r="http://schemas.openxmlformats.org/officeDocument/2006/relationships">
+  <p:cSld>
+    <p:spTree>
+      <p:nvGrpSpPr>
+        <p:cNvPr id="1" name=""/>
+        <p:cNvGrpSpPr/>
+        <p:nvPr/>
+      </p:nvGrpSpPr>
+      <p:grpSpPr/>
+      <p:sp>
+        <p:nvSpPr>
+          <p:cNvPr id="2" name="TextBox 1"/>
+          <p:cNvSpPr txBox="1"/>
+          <p:nvPr/>
+        </p:nvSpPr>
+        <p:spPr>
+          <a:xfrm>
+            <a:off x="502920" y="256032"/>
+            <a:ext cx="11185855" cy="914400"/>
+          </a:xfrm>
+          <a:prstGeom prst="rect">
+            <a:avLst/>
+          </a:prstGeom>
+          <a:noFill/>
+        </p:spPr>
+        <p:txBody>
+          <a:bodyPr wrap="square">
+            <a:spAutoFit/>
+          </a:bodyPr>
+          <a:lstStyle/>
+          <a:p>
+            <a:pPr>
+              <a:spcAft>
+                <a:spcPts val="200"/>
+              </a:spcAft>
+            </a:pPr>
+            <a:r>
+              <a:rPr sz="3000" b="1" i="0">
+                <a:solidFill>
+                  <a:srgbClr val="1F3864"/>
+                </a:solidFill>
+                <a:latin typeface="Calibri"/>
+              </a:rPr>
+              <a:t>Backup - fusion seen on the maps</a:t>
+            </a:r>
+          </a:p>
+          <a:p>
+            <a:pPr>
+              <a:spcAft>
+                <a:spcPts val="200"/>
+              </a:spcAft>
+            </a:pPr>
+            <a:r>
+              <a:rPr sz="1600" b="0" i="1">
+                <a:solidFill>
+                  <a:srgbClr val="595959"/>
+                </a:solidFill>
+                <a:latin typeface="Calibri"/>
+              </a:rPr>
+              <a:t>cross-scan noise panels: summed vs learned, held-out SNR annotated</a:t>
+            </a:r>
+          </a:p>
+        </p:txBody>
+      </p:sp>
+      <p:pic>
+        <p:nvPicPr>
+          <p:cNvPr id="3" name="Picture 2" descr="fusion_showcase.png"/>
+          <p:cNvPicPr>
+            <a:picLocks noChangeAspect="1"/>
+          </p:cNvPicPr>
+          <p:nvPr/>
+        </p:nvPicPr>
+        <p:blipFill>
+          <a:blip r:embed="rId2"/>
+          <a:stretch>
+            <a:fillRect/>
+          </a:stretch>
+        </p:blipFill>
+        <p:spPr>
+          <a:xfrm>
+            <a:off x="1892807" y="1325880"/>
+            <a:ext cx="8301278" cy="5349240"/>
+          </a:xfrm>
+          <a:prstGeom prst="rect">
+            <a:avLst/>
+          </a:prstGeom>
+        </p:spPr>
+      </p:pic>
+    </p:spTree>
+  </p:cSld>
+  <p:clrMapOvr>
+    <a:masterClrMapping/>
+  </p:clrMapOvr>
+</p:sld>
+</file>
+
+<file path=ppt/slides/slide12.xml><?xml version="1.0" encoding="utf-8"?>
+<p:sld xmlns:a="http://schemas.openxmlformats.org/drawingml/2006/main" xmlns:p="http://schemas.openxmlformats.org/presentationml/2006/main" xmlns:r="http://schemas.openxmlformats.org/officeDocument/2006/relationships">
+  <p:cSld>
+    <p:spTree>
+      <p:nvGrpSpPr>
+        <p:cNvPr id="1" name=""/>
+        <p:cNvGrpSpPr/>
+        <p:nvPr/>
+      </p:nvGrpSpPr>
+      <p:grpSpPr/>
+      <p:sp>
+        <p:nvSpPr>
+          <p:cNvPr id="2" name="TextBox 1"/>
+          <p:cNvSpPr txBox="1"/>
+          <p:nvPr/>
+        </p:nvSpPr>
+        <p:spPr>
+          <a:xfrm>
+            <a:off x="502920" y="256032"/>
+            <a:ext cx="11185855" cy="914400"/>
+          </a:xfrm>
+          <a:prstGeom prst="rect">
+            <a:avLst/>
+          </a:prstGeom>
+          <a:noFill/>
+        </p:spPr>
+        <p:txBody>
+          <a:bodyPr wrap="square">
+            <a:spAutoFit/>
+          </a:bodyPr>
+          <a:lstStyle/>
+          <a:p>
+            <a:pPr>
+              <a:spcAft>
+                <a:spcPts val="200"/>
+              </a:spcAft>
+            </a:pPr>
+            <a:r>
+              <a:rPr sz="3000" b="1" i="0">
+                <a:solidFill>
+                  <a:srgbClr val="1F3864"/>
+                </a:solidFill>
+                <a:latin typeface="Calibri"/>
+              </a:rPr>
+              <a:t>Backup - why not the individual take-off angles?</a:t>
+            </a:r>
+          </a:p>
+        </p:txBody>
+      </p:sp>
+      <p:sp>
+        <p:nvSpPr>
+          <p:cNvPr id="3" name="TextBox 2"/>
+          <p:cNvSpPr txBox="1"/>
+          <p:nvPr/>
+        </p:nvSpPr>
+        <p:spPr>
+          <a:xfrm>
+            <a:off x="822960" y="1645920"/>
+            <a:ext cx="10545775" cy="4023360"/>
+          </a:xfrm>
+          <a:prstGeom prst="rect">
+            <a:avLst/>
+          </a:prstGeom>
+          <a:noFill/>
+        </p:spPr>
+        <p:txBody>
+          <a:bodyPr wrap="square">
+            <a:spAutoFit/>
+          </a:bodyPr>
+          <a:lstStyle/>
+          <a:p>
+            <a:pPr>
+              <a:spcAft>
+                <a:spcPts val="1400"/>
+              </a:spcAft>
+            </a:pPr>
+            <a:r>
+              <a:rPr sz="1700" b="0" i="0">
+                <a:solidFill>
+                  <a:srgbClr val="595959"/>
+                </a:solidFill>
+                <a:latin typeface="Calibri"/>
+              </a:rPr>
+              <a:t>•  </a:t>
+            </a:r>
+            <a:r>
+              <a:rPr sz="1700" b="0" i="0">
+                <a:solidFill>
+                  <a:srgbClr val="262626"/>
+                </a:solidFill>
+                <a:latin typeface="Calibri"/>
+              </a:rPr>
+              <a:t>Fitting both take-off angles directly returns ~1e5-degree uncertainties: with a single tilt the shift is first-order in the RESPONSE, second-order in the asymmetry</a:t>
+            </a:r>
+          </a:p>
+          <a:p>
+            <a:pPr>
+              <a:spcAft>
+                <a:spcPts val="1400"/>
+              </a:spcAft>
+            </a:pPr>
+            <a:r>
+              <a:rPr sz="1700" b="0" i="0">
+                <a:solidFill>
+                  <a:srgbClr val="595959"/>
+                </a:solidFill>
+                <a:latin typeface="Calibri"/>
+              </a:rPr>
+              <a:t>•  </a:t>
+            </a:r>
+            <a:r>
+              <a:rPr sz="1700" b="1" i="0">
+                <a:solidFill>
+                  <a:srgbClr val="262626"/>
+                </a:solidFill>
+                <a:latin typeface="Calibri"/>
+              </a:rPr>
+              <a:t>Identifiable: the lever arm s = 0.53 ± 0.10 deg/deg - how fast the effective angles move per degree of tilt</a:t>
+            </a:r>
+          </a:p>
+          <a:p>
+            <a:pPr>
+              <a:spcAft>
+                <a:spcPts val="1400"/>
+              </a:spcAft>
+            </a:pPr>
+            <a:r>
+              <a:rPr sz="1700" b="0" i="0">
+                <a:solidFill>
+                  <a:srgbClr val="595959"/>
+                </a:solidFill>
+                <a:latin typeface="Calibri"/>
+              </a:rPr>
+              <a:t>•  </a:t>
+            </a:r>
+            <a:r>
+              <a:rPr sz="1700" b="0" i="0">
+                <a:solidFill>
+                  <a:srgbClr val="262626"/>
+                </a:solidFill>
+                <a:latin typeface="Calibri"/>
+              </a:rPr>
+              <a:t>With the builder-confirmed mean take-off angle psi, the per-detector effective angles follow as psi ± s·theta (pending confirmation)</a:t>
+            </a:r>
+          </a:p>
+          <a:p>
+            <a:pPr>
+              <a:spcAft>
+                <a:spcPts val="1400"/>
+              </a:spcAft>
+            </a:pPr>
+            <a:r>
+              <a:rPr sz="1700" b="0" i="0">
+                <a:solidFill>
+                  <a:srgbClr val="595959"/>
+                </a:solidFill>
+                <a:latin typeface="Calibri"/>
+              </a:rPr>
+              <a:t>•  </a:t>
+            </a:r>
+            <a:r>
+              <a:rPr sz="1700" b="0" i="0">
+                <a:solidFill>
+                  <a:srgbClr val="262626"/>
+                </a:solidFill>
+                <a:latin typeface="Calibri"/>
+              </a:rPr>
+              <a:t>Same story for the tilt angle itself: foreshortening at 7.7 deg sits near the registration floor (a no-tilt control pair returns “5.3 deg”) - hence the upper bound</a:t>
             </a:r>
           </a:p>
         </p:txBody>
@@ -7226,6 +7645,40 @@
               <a:t> (six lines from Fe up, Pb Ll +69 %; Ca/Ti kept on the sum)</a:t>
             </a:r>
           </a:p>
+          <a:p>
+            <a:pPr>
+              <a:spcAft>
+                <a:spcPts val="800"/>
+              </a:spcAft>
+            </a:pPr>
+            <a:r>
+              <a:rPr sz="1700" b="0" i="0">
+                <a:solidFill>
+                  <a:srgbClr val="595959"/>
+                </a:solidFill>
+                <a:latin typeface="Calibri"/>
+              </a:rPr>
+              <a:t>•  </a:t>
+            </a:r>
+            <a:r>
+              <a:rPr sz="1500" b="1" i="0">
+                <a:solidFill>
+                  <a:srgbClr val="262626"/>
+                </a:solidFill>
+                <a:latin typeface="Calibri"/>
+              </a:rPr>
+              <a:t>Canvas relief from one scan</a:t>
+            </a:r>
+            <a:r>
+              <a:rPr sz="1500" b="0" i="0">
+                <a:solidFill>
+                  <a:srgbClr val="262626"/>
+                </a:solidFill>
+                <a:latin typeface="Calibri"/>
+              </a:rPr>
+              <a:t>: local-slope map from the per-pixel ratio residuals, reproducible at r = 0.73 and tilt-law consistent (chi2/dof 0.85)</a:t>
+            </a:r>
+          </a:p>
         </p:txBody>
       </p:sp>
       <p:pic>

</xml_diff>

<commit_message>
Update the dual-detector talk with the pending instrument-builder answers
The schematic generator gains parameters (scale, geometry, labels) so
scripts/18_poster_figures.py can reuse it at poster size; slide text
updated with the builder's partial reply (tube settings and working
distance confirmed, but for a different serial number, so per-detector
mounting is still an open request). Kept alongside is Maja's reviewed
copy of the talk (affiliation order, terminology, and figure-choice
feedback) as a record of that review round.
</commit_message>
<xml_diff>
--- a/presentation/dual_detector_talk.pptx
+++ b/presentation/dual_detector_talk.pptx
@@ -733,7 +733,7 @@
           <a:lstStyle/>
           <a:p>
             <a:r>
-              <a:t>BACKUP - not part of the 8:00. Use if the abstract-vs-talk difference on viewing angles comes up: the abstract promised per-detector angles; with one tilt only the response is identifiable, and the per-detector values need the nominal head geometry from the instrument builder.</a:t>
+              <a:t>BACKUP - not part of the 8:00. Use if the abstract-vs-talk difference on viewing angles comes up: the abstract promised per-detector angles; with one tilt only the response is identifiable, and the per-detector values need the nominal head geometry from the instrument builder. Status: the builder sent tube settings (40 kV, 50 uA), 2 cm working distance and a spec sheet - but for s/n 10791, not our units; per-detector mounting is still requested.</a:t>
             </a:r>
           </a:p>
         </p:txBody>
@@ -1108,7 +1108,7 @@
           </a:p>
           <a:p>
             <a:r>
-              <a:t>The frontal curve is explained by detector properties alone. The surprise: the fitted low-energy absorber is the equivalent of a millimetre of beryllium - no window is that thick. It corresponds to 15-20 cm of air, so one detector must sit further away or behind a collimator. We learned that about the hardware without opening it.</a:t>
+              <a:t>The frontal curve is explained by detector properties alone. The surprise: the fitted low-energy absorber is the equivalent of a millimetre of beryllium - no window is that thick. It corresponds to 15-20 cm of air, so one detector must sit further away or behind a collimator. We learned that about the hardware without opening it. Manufacturer specs since received (X-123SDD family): nominal window 8-12.5 um Be and 500 um Si - the fitted reference matches the factory value; snout extenders up to 9 in exist, so a long-extender mounting of 19511 is the concrete candidate. Per-unit configuration still pending.</a:t>
             </a:r>
           </a:p>
         </p:txBody>

</xml_diff>